<commit_message>
Add team members: Adarsh Gupta, Aryan Sandilya, Ujjwal Pratap Singh
</commit_message>
<xml_diff>
--- a/docs/SRM_SpaceX_Submission_ppt.pptx
+++ b/docs/SRM_SpaceX_Submission_ppt.pptx
@@ -119,17 +119,17 @@
   <p:extLst>
     <p:ext uri="{521415D9-36F7-43E2-AB2F-B90AF26B5E84}">
       <p14:sectionLst xmlns:p14="http://schemas.microsoft.com/office/powerpoint/2010/main">
-        <p14:section name="Introduction" id="{59000cfe-19c5-bfed-bc58-ed6f3a8c11c6}">
+        <p14:section name="Introduction" id="{a1a0c03b-7bbb-f841-251c-e92b55427bd9}">
           <p14:sldIdLst>
             <p14:sldId id="256"/>
           </p14:sldIdLst>
         </p14:section>
-        <p14:section name="Problem" id="{3559558f-f569-b2b7-64cc-fcf6b9cdc1e3}">
+        <p14:section name="Problem" id="{56e02fcf-b3ab-b3b7-84a6-66b24fa311d8}">
           <p14:sldIdLst>
             <p14:sldId id="257"/>
           </p14:sldIdLst>
         </p14:section>
-        <p14:section name="Solution" id="{79207e7e-fe07-3ce2-c487-fcfe9dc810f9}">
+        <p14:section name="Solution" id="{22c45b41-1930-ec6a-936c-7377a6cefc3c}">
           <p14:sldIdLst>
             <p14:sldId id="258"/>
             <p14:sldId id="259"/>
@@ -137,14 +137,14 @@
             <p14:sldId id="261"/>
           </p14:sldIdLst>
         </p14:section>
-        <p14:section name="Results" id="{6372dfc8-83b3-2fcb-088e-9d7148721e6a}">
+        <p14:section name="Results" id="{1ec660b3-3246-934b-fb14-2122d54613f2}">
           <p14:sldIdLst>
             <p14:sldId id="262"/>
             <p14:sldId id="263"/>
             <p14:sldId id="264"/>
           </p14:sldIdLst>
         </p14:section>
-        <p14:section name="Wrap-up" id="{f32e25a9-5976-6ec0-859f-ce80c460445a}">
+        <p14:section name="Wrap-up" id="{e6273672-3c1a-cd4f-501e-c0e481d23bd1}">
           <p14:sldIdLst>
             <p14:sldId id="265"/>
             <p14:sldId id="266"/>
@@ -3102,7 +3102,7 @@
                   <a:schemeClr val="bg2"/>
                 </a:solidFill>
               </a:rPr>
-              <a:t>SRM Institute of Science and Technology   ·   Members: &lt;Member 1&gt;, &lt;Member 2&gt;, &lt;Member 3&gt;</a:t>
+              <a:t>SRM Institute of Science and Technology   ·   Members: Adarsh Gupta, Aryan Sandilya, Ujjwal Pratap Singh</a:t>
             </a:r>
             <a:endParaRPr lang="en-US" sz="1600" dirty="0"/>
           </a:p>

</xml_diff>

<commit_message>
Deck: link demo video on Google Drive
</commit_message>
<xml_diff>
--- a/docs/SRM_SpaceX_Submission_ppt.pptx
+++ b/docs/SRM_SpaceX_Submission_ppt.pptx
@@ -119,17 +119,17 @@
   <p:extLst>
     <p:ext uri="{521415D9-36F7-43E2-AB2F-B90AF26B5E84}">
       <p14:sectionLst xmlns:p14="http://schemas.microsoft.com/office/powerpoint/2010/main">
-        <p14:section name="Introduction" id="{a1a0c03b-7bbb-f841-251c-e92b55427bd9}">
+        <p14:section name="Introduction" id="{441d86a7-b03a-bc42-781c-d1aaa9bf9fc2}">
           <p14:sldIdLst>
             <p14:sldId id="256"/>
           </p14:sldIdLst>
         </p14:section>
-        <p14:section name="Problem" id="{56e02fcf-b3ab-b3b7-84a6-66b24fa311d8}">
+        <p14:section name="Problem" id="{fbd196c2-18af-361f-2a27-6a8e8f4217fe}">
           <p14:sldIdLst>
             <p14:sldId id="257"/>
           </p14:sldIdLst>
         </p14:section>
-        <p14:section name="Solution" id="{22c45b41-1930-ec6a-936c-7377a6cefc3c}">
+        <p14:section name="Solution" id="{bcfefcc0-6063-1ff1-9964-29619f31145c}">
           <p14:sldIdLst>
             <p14:sldId id="258"/>
             <p14:sldId id="259"/>
@@ -137,14 +137,14 @@
             <p14:sldId id="261"/>
           </p14:sldIdLst>
         </p14:section>
-        <p14:section name="Results" id="{1ec660b3-3246-934b-fb14-2122d54613f2}">
+        <p14:section name="Results" id="{fd2e39f0-7027-b47b-1bb7-0fe5c9984326}">
           <p14:sldIdLst>
             <p14:sldId id="262"/>
             <p14:sldId id="263"/>
             <p14:sldId id="264"/>
           </p14:sldIdLst>
         </p14:section>
-        <p14:section name="Wrap-up" id="{e6273672-3c1a-cd4f-501e-c0e481d23bd1}">
+        <p14:section name="Wrap-up" id="{064479b7-ad60-c323-a799-0c66aff0d847}">
           <p14:sldIdLst>
             <p14:sldId id="265"/>
             <p14:sldId id="266"/>
@@ -5487,12 +5487,19 @@
               <a:buNone/>
             </a:pPr>
             <a:r>
-              <a:rPr lang="en-US" sz="1600" dirty="0">
+              <a:rPr lang="en-US" sz="1600" u="sng" dirty="0">
                 <a:solidFill>
                   <a:schemeClr val="bg2"/>
                 </a:solidFill>
-              </a:rPr>
-              <a:t>&lt;YouTube / Drive link&gt;</a:t>
+                <a:hlinkClick r:id="rId2" invalidUrl="" action="" tgtFrame="" tooltip="" history="1" highlightClick="0" endSnd="0">
+                  <a:extLst>
+                    <a:ext uri="{A12FA001-AC4F-418D-AE19-62706E023703}">
+                      <ahyp:hlinkClr xmlns:ahyp="http://schemas.microsoft.com/office/drawing/2018/hyperlinkcolor" val="tx"/>
+                    </a:ext>
+                  </a:extLst>
+                </a:hlinkClick>
+              </a:rPr>
+              <a:t>Google Drive</a:t>
             </a:r>
             <a:endParaRPr lang="en-US" sz="1600" dirty="0"/>
           </a:p>

</xml_diff>